<commit_message>
docs: consolidar materiales y estado de lanzamiento
</commit_message>
<xml_diff>
--- a/entregables/deck-comercial-padelclub-os.pptx
+++ b/entregables/deck-comercial-padelclub-os.pptx
@@ -10,6 +10,7 @@
   <p:sldIdLst>
     <p:sldId xmlns:r="http://schemas.openxmlformats.org/officeDocument/2006/relationships" id="256" r:id="R3dd87e5efca249a0"/>
     <p:sldId xmlns:r="http://schemas.openxmlformats.org/officeDocument/2006/relationships" id="257" r:id="Re615d51a5bd14f91"/>
+    <p:sldId xmlns:ns0="http://schemas.openxmlformats.org/officeDocument/2006/relationships" id="270" ns0:id="rId20"/>
     <p:sldId xmlns:r="http://schemas.openxmlformats.org/officeDocument/2006/relationships" id="258" r:id="R6ce9558fe8dc4e07"/>
     <p:sldId xmlns:r="http://schemas.openxmlformats.org/officeDocument/2006/relationships" id="259" r:id="Rd102dc22299d4d8d"/>
     <p:sldId xmlns:r="http://schemas.openxmlformats.org/officeDocument/2006/relationships" id="260" r:id="Rf4980fc132d043f9"/>
@@ -548,7 +549,11 @@
         <p:txBody>
           <a:bodyPr xmlns:a="http://schemas.openxmlformats.org/drawingml/2006/main"/>
           <a:lstStyle xmlns:a="http://schemas.openxmlformats.org/drawingml/2006/main"/>
-          <a:p xmlns:a="http://schemas.openxmlformats.org/drawingml/2006/main"/>
+          <a:p xmlns:a="http://schemas.openxmlformats.org/drawingml/2006/main">
+            <a:r>
+              <a:t>Abre con la idea central: no vendemos 'un programa de reservas', vendemos que toda la operación comparta el mismo dato. Pregunta inicial útil: ¿cómo gestionáis hoy una reserva que cambia de hora?</a:t>
+            </a:r>
+          </a:p>
         </p:txBody>
       </p:sp>
       <p:sp>
@@ -614,7 +619,11 @@
         <p:txBody>
           <a:bodyPr xmlns:a="http://schemas.openxmlformats.org/drawingml/2006/main"/>
           <a:lstStyle xmlns:a="http://schemas.openxmlformats.org/drawingml/2006/main"/>
-          <a:p xmlns:a="http://schemas.openxmlformats.org/drawingml/2006/main"/>
+          <a:p xmlns:a="http://schemas.openxmlformats.org/drawingml/2006/main">
+            <a:r>
+              <a:t>El proceso de cambio en 4 pasos con criterio de salida verificable. Transmite que no dejamos al club solo con un enlace y suerte.</a:t>
+            </a:r>
+          </a:p>
         </p:txBody>
       </p:sp>
       <p:sp>
@@ -680,7 +689,11 @@
         <p:txBody>
           <a:bodyPr xmlns:a="http://schemas.openxmlformats.org/drawingml/2006/main"/>
           <a:lstStyle xmlns:a="http://schemas.openxmlformats.org/drawingml/2006/main"/>
-          <a:p xmlns:a="http://schemas.openxmlformats.org/drawingml/2006/main"/>
+          <a:p xmlns:a="http://schemas.openxmlformats.org/drawingml/2006/main">
+            <a:r>
+              <a:t>Base técnica en lenguaje de negocio: multi-club, roles, trazabilidad, PWA sin instalaciones, comunicaciones y privacidad. No entrar en detalle técnico salvo pregunta expresa.</a:t>
+            </a:r>
+          </a:p>
         </p:txBody>
       </p:sp>
       <p:sp>
@@ -746,7 +759,11 @@
         <p:txBody>
           <a:bodyPr xmlns:a="http://schemas.openxmlformats.org/drawingml/2006/main"/>
           <a:lstStyle xmlns:a="http://schemas.openxmlformats.org/drawingml/2006/main"/>
-          <a:p xmlns:a="http://schemas.openxmlformats.org/drawingml/2006/main"/>
+          <a:p xmlns:a="http://schemas.openxmlformats.org/drawingml/2006/main">
+            <a:r>
+              <a:t>El piloto reduce el riesgo percibido: semana 0, formación, revisión a 24 horas y decisión a 7 días. Sin pagos reales durante el piloto. Es la alternativa a 'firmar a ciegas'.</a:t>
+            </a:r>
+          </a:p>
         </p:txBody>
       </p:sp>
       <p:sp>
@@ -812,7 +829,11 @@
         <p:txBody>
           <a:bodyPr xmlns:a="http://schemas.openxmlformats.org/drawingml/2006/main"/>
           <a:lstStyle xmlns:a="http://schemas.openxmlformats.org/drawingml/2006/main"/>
-          <a:p xmlns:a="http://schemas.openxmlformats.org/drawingml/2006/main"/>
+          <a:p xmlns:a="http://schemas.openxmlformats.org/drawingml/2006/main">
+            <a:r>
+              <a:t>Diapositiva de honestidad: qué incluye y qué no. Adelántate a las comparativas con otros productos; vender lo que existe evita devoluciones de confianza después.</a:t>
+            </a:r>
+          </a:p>
         </p:txBody>
       </p:sp>
       <p:sp>
@@ -878,7 +899,11 @@
         <p:txBody>
           <a:bodyPr xmlns:a="http://schemas.openxmlformats.org/drawingml/2006/main"/>
           <a:lstStyle xmlns:a="http://schemas.openxmlformats.org/drawingml/2006/main"/>
-          <a:p xmlns:a="http://schemas.openxmlformats.org/drawingml/2006/main"/>
+          <a:p xmlns:a="http://schemas.openxmlformats.org/drawingml/2006/main">
+            <a:r>
+              <a:t>Cierre con acción concreta: una demo con SUS horarios y SUS pistas. Pide los 5 datos de la lista antes de terminar la reunión y agenda la demo en ese momento.</a:t>
+            </a:r>
+          </a:p>
         </p:txBody>
       </p:sp>
       <p:sp>
@@ -902,6 +927,76 @@
   </p:cSld>
   <p:clrMapOvr>
     <a:masterClrMapping xmlns:a="http://schemas.openxmlformats.org/drawingml/2006/main"/>
+  </p:clrMapOvr>
+</p:notes>
+</file>
+
+<file path=ppt/notesSlides/notesSlide15.xml><?xml version="1.0" encoding="utf-8"?>
+<p:notes xmlns:a="http://schemas.openxmlformats.org/drawingml/2006/main" xmlns:p="http://schemas.openxmlformats.org/presentationml/2006/main" xmlns:r="http://schemas.openxmlformats.org/officeDocument/2006/relationships">
+  <p:cSld>
+    <p:spTree>
+      <p:nvGrpSpPr>
+        <p:cNvPr id="1" name=""/>
+        <p:cNvGrpSpPr/>
+        <p:nvPr/>
+      </p:nvGrpSpPr>
+      <p:grpSpPr>
+        <a:xfrm>
+          <a:off x="0" y="0"/>
+          <a:ext cx="0" cy="0"/>
+          <a:chOff x="0" y="0"/>
+          <a:chExt cx="0" cy="0"/>
+        </a:xfrm>
+      </p:grpSpPr>
+      <p:sp>
+        <p:nvSpPr>
+          <p:cNvPr id="2" name="Slide Image Placeholder 1"/>
+          <p:cNvSpPr>
+            <a:spLocks noGrp="1"/>
+          </p:cNvSpPr>
+          <p:nvPr>
+            <p:ph type="sldImg" idx="2"/>
+          </p:nvPr>
+        </p:nvSpPr>
+        <p:spPr/>
+      </p:sp>
+      <p:sp>
+        <p:nvSpPr>
+          <p:cNvPr id="3" name="Notes Placeholder 2"/>
+          <p:cNvSpPr>
+            <a:spLocks noGrp="1"/>
+          </p:cNvSpPr>
+          <p:nvPr>
+            <p:ph type="body" idx="3" sz="quarter"/>
+          </p:nvPr>
+        </p:nvSpPr>
+        <p:spPr/>
+        <p:txBody>
+          <a:bodyPr/>
+          <a:lstStyle/>
+          <a:p>
+            <a:r>
+              <a:t>Esta tabla es el resumen comercial de la reunión. Léela por filas y deténte donde el club reaccione. Cierra con la frase inferior: no les cambiamos la caja, les damos control sobre ella.</a:t>
+            </a:r>
+          </a:p>
+        </p:txBody>
+      </p:sp>
+      <p:sp>
+        <p:nvSpPr>
+          <p:cNvPr id="4" name="Slide Number Placeholder 3"/>
+          <p:cNvSpPr>
+            <a:spLocks noGrp="1"/>
+          </p:cNvSpPr>
+          <p:nvPr>
+            <p:ph type="sldNum" idx="5" sz="quarter"/>
+          </p:nvPr>
+        </p:nvSpPr>
+        <p:spPr/>
+      </p:sp>
+    </p:spTree>
+  </p:cSld>
+  <p:clrMapOvr>
+    <a:masterClrMapping/>
   </p:clrMapOvr>
 </p:notes>
 </file>
@@ -944,7 +1039,11 @@
         <p:txBody>
           <a:bodyPr xmlns:a="http://schemas.openxmlformats.org/drawingml/2006/main"/>
           <a:lstStyle xmlns:a="http://schemas.openxmlformats.org/drawingml/2006/main"/>
-          <a:p xmlns:a="http://schemas.openxmlformats.org/drawingml/2006/main"/>
+          <a:p xmlns:a="http://schemas.openxmlformats.org/drawingml/2006/main">
+            <a:r>
+              <a:t>Deja que el club se reconozca en los tres dolores. No critiques su sistema actual: WhatsApp y Excel 'funcionan', pero a costa de memoria y horas. La cadena de la derecha suele generar asentimiento inmediato.</a:t>
+            </a:r>
+          </a:p>
         </p:txBody>
       </p:sp>
       <p:sp>
@@ -1010,7 +1109,11 @@
         <p:txBody>
           <a:bodyPr xmlns:a="http://schemas.openxmlformats.org/drawingml/2006/main"/>
           <a:lstStyle xmlns:a="http://schemas.openxmlformats.org/drawingml/2006/main"/>
-          <a:p xmlns:a="http://schemas.openxmlformats.org/drawingml/2006/main"/>
+          <a:p xmlns:a="http://schemas.openxmlformats.org/drawingml/2006/main">
+            <a:r>
+              <a:t>Mensaje clave: una sola operación, dos experiencias. El equipo gana velocidad y control; el jugador gana autonomía con la marca del club. Evita entrar en detalle de pantallas: eso es la demo.</a:t>
+            </a:r>
+          </a:p>
         </p:txBody>
       </p:sp>
       <p:sp>
@@ -1076,7 +1179,11 @@
         <p:txBody>
           <a:bodyPr xmlns:a="http://schemas.openxmlformats.org/drawingml/2006/main"/>
           <a:lstStyle xmlns:a="http://schemas.openxmlformats.org/drawingml/2006/main"/>
-          <a:p xmlns:a="http://schemas.openxmlformats.org/drawingml/2006/main"/>
+          <a:p xmlns:a="http://schemas.openxmlformats.org/drawingml/2006/main">
+            <a:r>
+              <a:t>La agenda es la fuente de verdad. Destaca lo que no se ve en la miniatura: reagendar, repetir, clases fijas y lista de espera con aviso automático. Es el bloque con más diferencia frente a WhatsApp.</a:t>
+            </a:r>
+          </a:p>
         </p:txBody>
       </p:sp>
       <p:sp>
@@ -1142,7 +1249,11 @@
         <p:txBody>
           <a:bodyPr xmlns:a="http://schemas.openxmlformats.org/drawingml/2006/main"/>
           <a:lstStyle xmlns:a="http://schemas.openxmlformats.org/drawingml/2006/main"/>
-          <a:p xmlns:a="http://schemas.openxmlformats.org/drawingml/2006/main"/>
+          <a:p xmlns:a="http://schemas.openxmlformats.org/drawingml/2006/main">
+            <a:r>
+              <a:t>Punto delicado y a la vez fortaleza: el cobro sigue siendo presencial (sin TPV, sin checkout online de reservas), pero con estado por jugador y trazabilidad. Sé transparente aquí: genera confianza.</a:t>
+            </a:r>
+          </a:p>
         </p:txBody>
       </p:sp>
       <p:sp>
@@ -1208,7 +1319,11 @@
         <p:txBody>
           <a:bodyPr xmlns:a="http://schemas.openxmlformats.org/drawingml/2006/main"/>
           <a:lstStyle xmlns:a="http://schemas.openxmlformats.org/drawingml/2006/main"/>
-          <a:p xmlns:a="http://schemas.openxmlformats.org/drawingml/2006/main"/>
+          <a:p xmlns:a="http://schemas.openxmlformats.org/drawingml/2006/main">
+            <a:r>
+              <a:t>Responde a la objeción 'no quiero volver a escribirlo todo'. Plantillas CSV compatibles con Excel en español, vista previa y validación por fila. Si el club usa otro software, el wizard de migración guía el proceso.</a:t>
+            </a:r>
+          </a:p>
         </p:txBody>
       </p:sp>
       <p:sp>
@@ -1274,7 +1389,11 @@
         <p:txBody>
           <a:bodyPr xmlns:a="http://schemas.openxmlformats.org/drawingml/2006/main"/>
           <a:lstStyle xmlns:a="http://schemas.openxmlformats.org/drawingml/2006/main"/>
-          <a:p xmlns:a="http://schemas.openxmlformats.org/drawingml/2006/main"/>
+          <a:p xmlns:a="http://schemas.openxmlformats.org/drawingml/2006/main">
+            <a:r>
+              <a:t>La comunidad retiene socios: partidas abiertas, competiciones con clasificación automática, ranking ELO, perfiles, chat y valoraciones. Vive donde el jugador ya reserva, no en otra app.</a:t>
+            </a:r>
+          </a:p>
         </p:txBody>
       </p:sp>
       <p:sp>
@@ -1340,7 +1459,11 @@
         <p:txBody>
           <a:bodyPr xmlns:a="http://schemas.openxmlformats.org/drawingml/2006/main"/>
           <a:lstStyle xmlns:a="http://schemas.openxmlformats.org/drawingml/2006/main"/>
-          <a:p xmlns:a="http://schemas.openxmlformats.org/drawingml/2006/main"/>
+          <a:p xmlns:a="http://schemas.openxmlformats.org/drawingml/2006/main">
+            <a:r>
+              <a:t>Un solo mensaje, tres canales, audiencia segmentada. Contrasta con el grupo de WhatsApp: aquí cada aviso llega una vez y a quien corresponde.</a:t>
+            </a:r>
+          </a:p>
         </p:txBody>
       </p:sp>
       <p:sp>
@@ -1406,7 +1529,11 @@
         <p:txBody>
           <a:bodyPr xmlns:a="http://schemas.openxmlformats.org/drawingml/2006/main"/>
           <a:lstStyle xmlns:a="http://schemas.openxmlformats.org/drawingml/2006/main"/>
-          <a:p xmlns:a="http://schemas.openxmlformats.org/drawingml/2006/main"/>
+          <a:p xmlns:a="http://schemas.openxmlformats.org/drawingml/2006/main">
+            <a:r>
+              <a:t>Analítica con datos reales del club: ocupación que descuenta bloqueos, altas con fecha real y zona horaria correcta. Diferenciador frente a paneles decorativos: aquí los números se pueden defender.</a:t>
+            </a:r>
+          </a:p>
         </p:txBody>
       </p:sp>
       <p:sp>
@@ -2152,7 +2279,7 @@
                   <a:srgbClr val="D8D2C7"/>
                 </a:solidFill>
               </a:rPr>
-              <a:t>Reservas, socios, cobros presenciales, competiciones y comunicación conectados para que el equipo trabaje con claridad.</a:t>
+              <a:t>Reservas, socios, cobros presenciales, competiciones y comunicación sobre un mismo dato. El equipo trabaja con claridad y el jugador reserva solo, desde el móvil, a cualquier hora.</a:t>
             </a:r>
           </a:p>
         </p:txBody>
@@ -2191,6 +2318,10 @@
             <a:prstDash val="solid"/>
           </a:ln>
         </p:spPr>
+        <p:txBody xmlns:a="http://schemas.openxmlformats.org/drawingml/2006/main">
+          <a:bodyPr/>
+          <a:p/>
+        </p:txBody>
       </p:sp>
       <p:sp>
         <p:nvSpPr>
@@ -2324,6 +2455,10 @@
             <a:prstDash val="solid"/>
           </a:ln>
         </p:spPr>
+        <p:txBody xmlns:a="http://schemas.openxmlformats.org/drawingml/2006/main">
+          <a:bodyPr/>
+          <a:p/>
+        </p:txBody>
       </p:sp>
       <p:sp>
         <p:nvSpPr>
@@ -2507,6 +2642,10 @@
             <a:prstDash val="solid"/>
           </a:ln>
         </p:spPr>
+        <p:txBody xmlns:a="http://schemas.openxmlformats.org/drawingml/2006/main">
+          <a:bodyPr/>
+          <a:p/>
+        </p:txBody>
       </p:sp>
       <p:sp>
         <p:nvSpPr>
@@ -2690,6 +2829,10 @@
             <a:prstDash val="solid"/>
           </a:ln>
         </p:spPr>
+        <p:txBody xmlns:a="http://schemas.openxmlformats.org/drawingml/2006/main">
+          <a:bodyPr/>
+          <a:p/>
+        </p:txBody>
       </p:sp>
       <p:sp>
         <p:nvSpPr>
@@ -2873,6 +3016,10 @@
             <a:prstDash val="solid"/>
           </a:ln>
         </p:spPr>
+        <p:txBody xmlns:a="http://schemas.openxmlformats.org/drawingml/2006/main">
+          <a:bodyPr/>
+          <a:p/>
+        </p:txBody>
       </p:sp>
       <p:sp>
         <p:nvSpPr>
@@ -3120,6 +3267,35 @@
                 </a:solidFill>
               </a:rPr>
               <a:t>padelclubos.com</a:t>
+            </a:r>
+          </a:p>
+        </p:txBody>
+      </p:sp>
+      <p:sp xmlns:a="http://schemas.openxmlformats.org/drawingml/2006/main">
+        <p:nvSpPr>
+          <p:cNvPr id="26" name="cover-kicker"/>
+          <p:cNvSpPr txBox="1"/>
+          <p:nvPr/>
+        </p:nvSpPr>
+        <p:spPr>
+          <a:xfrm>
+            <a:off x="685800" y="1371600"/>
+            <a:ext cx="7810500" cy="365760"/>
+          </a:xfrm>
+          <a:prstGeom prst="rect">
+            <a:avLst/>
+          </a:prstGeom>
+          <a:noFill/>
+        </p:spPr>
+        <p:txBody>
+          <a:bodyPr wrap="none">
+            <a:spAutoFit/>
+          </a:bodyPr>
+          <a:lstStyle/>
+          <a:p>
+            <a:r>
+              <a:rPr sz="1300" b="1"/>
+              <a:t>PADELCLUB OS · GESTIÓN INTEGRAL DE CLUBES DE PÁDEL</a:t>
             </a:r>
           </a:p>
         </p:txBody>
@@ -3287,6 +3463,10 @@
             <a:prstDash val="solid"/>
           </a:ln>
         </p:spPr>
+        <p:txBody xmlns:a="http://schemas.openxmlformats.org/drawingml/2006/main">
+          <a:bodyPr/>
+          <a:p/>
+        </p:txBody>
       </p:sp>
       <p:sp>
         <p:nvSpPr>
@@ -3322,6 +3502,10 @@
             <a:prstDash val="solid"/>
           </a:ln>
         </p:spPr>
+        <p:txBody xmlns:a="http://schemas.openxmlformats.org/drawingml/2006/main">
+          <a:bodyPr/>
+          <a:p/>
+        </p:txBody>
       </p:sp>
       <p:sp>
         <p:nvSpPr>
@@ -3507,6 +3691,10 @@
             <a:prstDash val="solid"/>
           </a:ln>
         </p:spPr>
+        <p:txBody xmlns:a="http://schemas.openxmlformats.org/drawingml/2006/main">
+          <a:bodyPr/>
+          <a:p/>
+        </p:txBody>
       </p:sp>
       <p:sp>
         <p:nvSpPr>
@@ -3542,6 +3730,10 @@
             <a:prstDash val="solid"/>
           </a:ln>
         </p:spPr>
+        <p:txBody xmlns:a="http://schemas.openxmlformats.org/drawingml/2006/main">
+          <a:bodyPr/>
+          <a:p/>
+        </p:txBody>
       </p:sp>
       <p:sp>
         <p:nvSpPr>
@@ -3727,6 +3919,10 @@
             <a:prstDash val="solid"/>
           </a:ln>
         </p:spPr>
+        <p:txBody xmlns:a="http://schemas.openxmlformats.org/drawingml/2006/main">
+          <a:bodyPr/>
+          <a:p/>
+        </p:txBody>
       </p:sp>
       <p:sp>
         <p:nvSpPr>
@@ -3762,6 +3958,10 @@
             <a:prstDash val="solid"/>
           </a:ln>
         </p:spPr>
+        <p:txBody xmlns:a="http://schemas.openxmlformats.org/drawingml/2006/main">
+          <a:bodyPr/>
+          <a:p/>
+        </p:txBody>
       </p:sp>
       <p:sp>
         <p:nvSpPr>
@@ -3947,6 +4147,10 @@
             <a:prstDash val="solid"/>
           </a:ln>
         </p:spPr>
+        <p:txBody xmlns:a="http://schemas.openxmlformats.org/drawingml/2006/main">
+          <a:bodyPr/>
+          <a:p/>
+        </p:txBody>
       </p:sp>
       <p:sp>
         <p:nvSpPr>
@@ -3982,6 +4186,10 @@
             <a:prstDash val="solid"/>
           </a:ln>
         </p:spPr>
+        <p:txBody xmlns:a="http://schemas.openxmlformats.org/drawingml/2006/main">
+          <a:bodyPr/>
+          <a:p/>
+        </p:txBody>
       </p:sp>
       <p:sp>
         <p:nvSpPr>
@@ -4215,6 +4423,10 @@
             <a:prstDash val="solid"/>
           </a:ln>
         </p:spPr>
+        <p:txBody xmlns:a="http://schemas.openxmlformats.org/drawingml/2006/main">
+          <a:bodyPr/>
+          <a:p/>
+        </p:txBody>
       </p:sp>
       <p:sp>
         <p:nvSpPr>
@@ -4311,7 +4523,7 @@
                   <a:srgbClr val="6E675D"/>
                 </a:solidFill>
               </a:rPr>
-              <a:t>10 / 14</a:t>
+              <a:t>11 / 15</a:t>
             </a:r>
           </a:p>
         </p:txBody>
@@ -4627,6 +4839,10 @@
             <a:prstDash val="solid"/>
           </a:ln>
         </p:spPr>
+        <p:txBody xmlns:a="http://schemas.openxmlformats.org/drawingml/2006/main">
+          <a:bodyPr/>
+          <a:p/>
+        </p:txBody>
       </p:sp>
       <p:sp>
         <p:nvSpPr>
@@ -4810,6 +5026,10 @@
             <a:prstDash val="solid"/>
           </a:ln>
         </p:spPr>
+        <p:txBody xmlns:a="http://schemas.openxmlformats.org/drawingml/2006/main">
+          <a:bodyPr/>
+          <a:p/>
+        </p:txBody>
       </p:sp>
       <p:sp>
         <p:nvSpPr>
@@ -4993,6 +5213,10 @@
             <a:prstDash val="solid"/>
           </a:ln>
         </p:spPr>
+        <p:txBody xmlns:a="http://schemas.openxmlformats.org/drawingml/2006/main">
+          <a:bodyPr/>
+          <a:p/>
+        </p:txBody>
       </p:sp>
       <p:sp>
         <p:nvSpPr>
@@ -5139,7 +5363,7 @@
                   <a:srgbClr val="6E675D"/>
                 </a:solidFill>
               </a:rPr>
-              <a:t>Portal responsive y PWA</a:t>
+              <a:t>Portal instalable (PWA), sin tiendas de aplicaciones</a:t>
             </a:r>
           </a:p>
         </p:txBody>
@@ -5176,6 +5400,10 @@
             <a:prstDash val="solid"/>
           </a:ln>
         </p:spPr>
+        <p:txBody xmlns:a="http://schemas.openxmlformats.org/drawingml/2006/main">
+          <a:bodyPr/>
+          <a:p/>
+        </p:txBody>
       </p:sp>
       <p:sp>
         <p:nvSpPr>
@@ -5359,6 +5587,10 @@
             <a:prstDash val="solid"/>
           </a:ln>
         </p:spPr>
+        <p:txBody xmlns:a="http://schemas.openxmlformats.org/drawingml/2006/main">
+          <a:bodyPr/>
+          <a:p/>
+        </p:txBody>
       </p:sp>
       <p:sp>
         <p:nvSpPr>
@@ -5542,6 +5774,10 @@
             <a:prstDash val="solid"/>
           </a:ln>
         </p:spPr>
+        <p:txBody xmlns:a="http://schemas.openxmlformats.org/drawingml/2006/main">
+          <a:bodyPr/>
+          <a:p/>
+        </p:txBody>
       </p:sp>
       <p:sp>
         <p:nvSpPr>
@@ -5575,6 +5811,10 @@
             <a:prstDash val="solid"/>
           </a:ln>
         </p:spPr>
+        <p:txBody xmlns:a="http://schemas.openxmlformats.org/drawingml/2006/main">
+          <a:bodyPr/>
+          <a:p/>
+        </p:txBody>
       </p:sp>
       <p:sp>
         <p:nvSpPr>
@@ -5671,7 +5911,7 @@
                   <a:srgbClr val="6E675D"/>
                 </a:solidFill>
               </a:rPr>
-              <a:t>11 / 14</a:t>
+              <a:t>12 / 15</a:t>
             </a:r>
           </a:p>
         </p:txBody>
@@ -5839,6 +6079,10 @@
             <a:prstDash val="solid"/>
           </a:ln>
         </p:spPr>
+        <p:txBody xmlns:a="http://schemas.openxmlformats.org/drawingml/2006/main">
+          <a:bodyPr/>
+          <a:p/>
+        </p:txBody>
       </p:sp>
       <p:sp>
         <p:nvSpPr>
@@ -5872,6 +6116,10 @@
             <a:prstDash val="solid"/>
           </a:ln>
         </p:spPr>
+        <p:txBody xmlns:a="http://schemas.openxmlformats.org/drawingml/2006/main">
+          <a:bodyPr/>
+          <a:p/>
+        </p:txBody>
       </p:sp>
       <p:sp>
         <p:nvSpPr>
@@ -6005,6 +6253,10 @@
             <a:prstDash val="solid"/>
           </a:ln>
         </p:spPr>
+        <p:txBody xmlns:a="http://schemas.openxmlformats.org/drawingml/2006/main">
+          <a:bodyPr/>
+          <a:p/>
+        </p:txBody>
       </p:sp>
       <p:sp>
         <p:nvSpPr>
@@ -6138,6 +6390,10 @@
             <a:prstDash val="solid"/>
           </a:ln>
         </p:spPr>
+        <p:txBody xmlns:a="http://schemas.openxmlformats.org/drawingml/2006/main">
+          <a:bodyPr/>
+          <a:p/>
+        </p:txBody>
       </p:sp>
       <p:sp>
         <p:nvSpPr>
@@ -6271,6 +6527,10 @@
             <a:prstDash val="solid"/>
           </a:ln>
         </p:spPr>
+        <p:txBody xmlns:a="http://schemas.openxmlformats.org/drawingml/2006/main">
+          <a:bodyPr/>
+          <a:p/>
+        </p:txBody>
       </p:sp>
       <p:sp>
         <p:nvSpPr>
@@ -6406,6 +6666,10 @@
             <a:prstDash val="solid"/>
           </a:ln>
         </p:spPr>
+        <p:txBody xmlns:a="http://schemas.openxmlformats.org/drawingml/2006/main">
+          <a:bodyPr/>
+          <a:p/>
+        </p:txBody>
       </p:sp>
       <p:sp>
         <p:nvSpPr>
@@ -6657,6 +6921,10 @@
             <a:prstDash val="solid"/>
           </a:ln>
         </p:spPr>
+        <p:txBody xmlns:a="http://schemas.openxmlformats.org/drawingml/2006/main">
+          <a:bodyPr/>
+          <a:p/>
+        </p:txBody>
       </p:sp>
       <p:sp>
         <p:nvSpPr>
@@ -6753,7 +7021,7 @@
                   <a:srgbClr val="6E675D"/>
                 </a:solidFill>
               </a:rPr>
-              <a:t>12 / 14</a:t>
+              <a:t>13 / 15</a:t>
             </a:r>
           </a:p>
         </p:txBody>
@@ -6921,6 +7189,10 @@
             <a:prstDash val="solid"/>
           </a:ln>
         </p:spPr>
+        <p:txBody xmlns:a="http://schemas.openxmlformats.org/drawingml/2006/main">
+          <a:bodyPr/>
+          <a:p/>
+        </p:txBody>
       </p:sp>
       <p:sp>
         <p:nvSpPr>
@@ -7141,6 +7413,10 @@
             <a:prstDash val="solid"/>
           </a:ln>
         </p:spPr>
+        <p:txBody xmlns:a="http://schemas.openxmlformats.org/drawingml/2006/main">
+          <a:bodyPr/>
+          <a:p/>
+        </p:txBody>
       </p:sp>
       <p:sp>
         <p:nvSpPr>
@@ -7392,6 +7668,10 @@
             <a:prstDash val="solid"/>
           </a:ln>
         </p:spPr>
+        <p:txBody xmlns:a="http://schemas.openxmlformats.org/drawingml/2006/main">
+          <a:bodyPr/>
+          <a:p/>
+        </p:txBody>
       </p:sp>
       <p:sp>
         <p:nvSpPr>
@@ -7488,7 +7768,7 @@
                   <a:srgbClr val="6E675D"/>
                 </a:solidFill>
               </a:rPr>
-              <a:t>13 / 14</a:t>
+              <a:t>14 / 15</a:t>
             </a:r>
           </a:p>
         </p:txBody>
@@ -7695,6 +7975,10 @@
             <a:prstDash val="solid"/>
           </a:ln>
         </p:spPr>
+        <p:txBody xmlns:a="http://schemas.openxmlformats.org/drawingml/2006/main">
+          <a:bodyPr/>
+          <a:p/>
+        </p:txBody>
       </p:sp>
       <p:sp>
         <p:nvSpPr>
@@ -7830,6 +8114,10 @@
             <a:prstDash val="solid"/>
           </a:ln>
         </p:spPr>
+        <p:txBody xmlns:a="http://schemas.openxmlformats.org/drawingml/2006/main">
+          <a:bodyPr/>
+          <a:p/>
+        </p:txBody>
       </p:sp>
       <p:sp>
         <p:nvSpPr>
@@ -8064,7 +8352,7 @@
                   <a:srgbClr val="A39C8E"/>
                 </a:solidFill>
               </a:rPr>
-              <a:t>14 / 14</a:t>
+              <a:t>15 / 15</a:t>
             </a:r>
           </a:p>
         </p:txBody>
@@ -8076,6 +8364,483 @@
       </p:ext>
     </p:extLst>
   </p:cSld>
+</p:sld>
+</file>
+
+<file path=ppt/slides/slide15.xml><?xml version="1.0" encoding="utf-8"?>
+<p:sld xmlns:a="http://schemas.openxmlformats.org/drawingml/2006/main" xmlns:p="http://schemas.openxmlformats.org/presentationml/2006/main" xmlns:r="http://schemas.openxmlformats.org/officeDocument/2006/relationships">
+  <p:cSld>
+    <p:spTree>
+      <p:nvGrpSpPr>
+        <p:cNvPr id="1" name=""/>
+        <p:cNvGrpSpPr/>
+        <p:nvPr/>
+      </p:nvGrpSpPr>
+      <p:grpSpPr/>
+      <p:sp>
+        <p:nvSpPr>
+          <p:cNvPr id="2" name="eyebrow"/>
+          <p:cNvSpPr txBox="1"/>
+          <p:nvPr/>
+        </p:nvSpPr>
+        <p:spPr>
+          <a:xfrm>
+            <a:off x="548640" y="411480"/>
+            <a:ext cx="5486400" cy="320040"/>
+          </a:xfrm>
+          <a:prstGeom prst="rect">
+            <a:avLst/>
+          </a:prstGeom>
+          <a:noFill/>
+        </p:spPr>
+        <p:txBody>
+          <a:bodyPr wrap="none">
+            <a:spAutoFit/>
+          </a:bodyPr>
+          <a:lstStyle/>
+          <a:p>
+            <a:r>
+              <a:rPr sz="1300" b="1"/>
+              <a:t>EL CAMBIO</a:t>
+            </a:r>
+          </a:p>
+        </p:txBody>
+      </p:sp>
+      <p:sp>
+        <p:nvSpPr>
+          <p:cNvPr id="3" name="slide-title"/>
+          <p:cNvSpPr txBox="1"/>
+          <p:nvPr/>
+        </p:nvSpPr>
+        <p:spPr>
+          <a:xfrm>
+            <a:off x="548640" y="777240"/>
+            <a:ext cx="11064240" cy="731520"/>
+          </a:xfrm>
+          <a:prstGeom prst="rect">
+            <a:avLst/>
+          </a:prstGeom>
+          <a:noFill/>
+        </p:spPr>
+        <p:txBody>
+          <a:bodyPr wrap="none">
+            <a:spAutoFit/>
+          </a:bodyPr>
+          <a:lstStyle/>
+          <a:p>
+            <a:r>
+              <a:rPr sz="3000" b="1"/>
+              <a:t>El mismo club, con y sin sistema</a:t>
+            </a:r>
+          </a:p>
+        </p:txBody>
+      </p:sp>
+      <p:graphicFrame>
+        <p:nvGraphicFramePr>
+          <p:cNvPr id="4" name="Table 3"/>
+          <p:cNvGraphicFramePr>
+            <a:graphicFrameLocks noGrp="1"/>
+          </p:cNvGraphicFramePr>
+          <p:nvPr/>
+        </p:nvGraphicFramePr>
+        <p:xfrm>
+          <a:off x="548640" y="1645920"/>
+          <a:ext cx="11064240" cy="4023360"/>
+        </p:xfrm>
+        <a:graphic>
+          <a:graphicData uri="http://schemas.openxmlformats.org/drawingml/2006/table">
+            <a:tbl>
+              <a:tblPr firstRow="1" bandRow="1">
+                <a:tableStyleId>{5C22544A-7EE6-4342-B048-85BDC9FD1C3A}</a:tableStyleId>
+              </a:tblPr>
+              <a:tblGrid>
+                <a:gridCol w="2103120"/>
+                <a:gridCol w="4023360"/>
+                <a:gridCol w="4937760"/>
+              </a:tblGrid>
+              <a:tr h="574765">
+                <a:tc>
+                  <a:txBody>
+                    <a:bodyPr/>
+                    <a:lstStyle/>
+                    <a:p>
+                      <a:r>
+                        <a:rPr sz="1300" b="1"/>
+                        <a:t>Área</a:t>
+                      </a:r>
+                    </a:p>
+                  </a:txBody>
+                  <a:tcPr/>
+                </a:tc>
+                <a:tc>
+                  <a:txBody>
+                    <a:bodyPr/>
+                    <a:lstStyle/>
+                    <a:p>
+                      <a:r>
+                        <a:rPr sz="1300" b="1"/>
+                        <a:t>Hoy</a:t>
+                      </a:r>
+                    </a:p>
+                  </a:txBody>
+                  <a:tcPr/>
+                </a:tc>
+                <a:tc>
+                  <a:txBody>
+                    <a:bodyPr/>
+                    <a:lstStyle/>
+                    <a:p>
+                      <a:r>
+                        <a:rPr sz="1300" b="1"/>
+                        <a:t>Con PadelClub OS</a:t>
+                      </a:r>
+                    </a:p>
+                  </a:txBody>
+                  <a:tcPr/>
+                </a:tc>
+              </a:tr>
+              <a:tr h="574765">
+                <a:tc>
+                  <a:txBody>
+                    <a:bodyPr/>
+                    <a:lstStyle/>
+                    <a:p>
+                      <a:r>
+                        <a:rPr sz="1300" b="1"/>
+                        <a:t>Reservas</a:t>
+                      </a:r>
+                    </a:p>
+                  </a:txBody>
+                  <a:tcPr/>
+                </a:tc>
+                <a:tc>
+                  <a:txBody>
+                    <a:bodyPr/>
+                    <a:lstStyle/>
+                    <a:p>
+                      <a:r>
+                        <a:rPr sz="1300"/>
+                        <a:t>Teléfono, WhatsApp y papel</a:t>
+                      </a:r>
+                    </a:p>
+                  </a:txBody>
+                  <a:tcPr/>
+                </a:tc>
+                <a:tc>
+                  <a:txBody>
+                    <a:bodyPr/>
+                    <a:lstStyle/>
+                    <a:p>
+                      <a:r>
+                        <a:rPr sz="1300"/>
+                        <a:t>Agenda única por pista + reserva online del jugador 24/7</a:t>
+                      </a:r>
+                    </a:p>
+                  </a:txBody>
+                  <a:tcPr/>
+                </a:tc>
+              </a:tr>
+              <a:tr h="574765">
+                <a:tc>
+                  <a:txBody>
+                    <a:bodyPr/>
+                    <a:lstStyle/>
+                    <a:p>
+                      <a:r>
+                        <a:rPr sz="1300" b="1"/>
+                        <a:t>Cambios y cancelaciones</a:t>
+                      </a:r>
+                    </a:p>
+                  </a:txBody>
+                  <a:tcPr/>
+                </a:tc>
+                <a:tc>
+                  <a:txBody>
+                    <a:bodyPr/>
+                    <a:lstStyle/>
+                    <a:p>
+                      <a:r>
+                        <a:rPr sz="1300"/>
+                        <a:t>Avisos sueltos y conflictos</a:t>
+                      </a:r>
+                    </a:p>
+                  </a:txBody>
+                  <a:tcPr/>
+                </a:tc>
+                <a:tc>
+                  <a:txBody>
+                    <a:bodyPr/>
+                    <a:lstStyle/>
+                    <a:p>
+                      <a:r>
+                        <a:rPr sz="1300"/>
+                        <a:t>Estado actualizado al momento para equipo y jugador</a:t>
+                      </a:r>
+                    </a:p>
+                  </a:txBody>
+                  <a:tcPr/>
+                </a:tc>
+              </a:tr>
+              <a:tr h="574765">
+                <a:tc>
+                  <a:txBody>
+                    <a:bodyPr/>
+                    <a:lstStyle/>
+                    <a:p>
+                      <a:r>
+                        <a:rPr sz="1300" b="1"/>
+                        <a:t>Cobro de reservas</a:t>
+                      </a:r>
+                    </a:p>
+                  </a:txBody>
+                  <a:tcPr/>
+                </a:tc>
+                <a:tc>
+                  <a:txBody>
+                    <a:bodyPr/>
+                    <a:lstStyle/>
+                    <a:p>
+                      <a:r>
+                        <a:rPr sz="1300"/>
+                        <a:t>«Creo que pagó»</a:t>
+                      </a:r>
+                    </a:p>
+                  </a:txBody>
+                  <a:tcPr/>
+                </a:tc>
+                <a:tc>
+                  <a:txBody>
+                    <a:bodyPr/>
+                    <a:lstStyle/>
+                    <a:p>
+                      <a:r>
+                        <a:rPr sz="1300"/>
+                        <a:t>Estado por jugador: cobrado, pendiente y quién lo registró</a:t>
+                      </a:r>
+                    </a:p>
+                  </a:txBody>
+                  <a:tcPr/>
+                </a:tc>
+              </a:tr>
+              <a:tr h="574765">
+                <a:tc>
+                  <a:txBody>
+                    <a:bodyPr/>
+                    <a:lstStyle/>
+                    <a:p>
+                      <a:r>
+                        <a:rPr sz="1300" b="1"/>
+                        <a:t>Competiciones</a:t>
+                      </a:r>
+                    </a:p>
+                  </a:txBody>
+                  <a:tcPr/>
+                </a:tc>
+                <a:tc>
+                  <a:txBody>
+                    <a:bodyPr/>
+                    <a:lstStyle/>
+                    <a:p>
+                      <a:r>
+                        <a:rPr sz="1300"/>
+                        <a:t>Cuadros en Excel</a:t>
+                      </a:r>
+                    </a:p>
+                  </a:txBody>
+                  <a:tcPr/>
+                </a:tc>
+                <a:tc>
+                  <a:txBody>
+                    <a:bodyPr/>
+                    <a:lstStyle/>
+                    <a:p>
+                      <a:r>
+                        <a:rPr sz="1300"/>
+                        <a:t>Liga, eliminatoria y grupos con clasificación automática</a:t>
+                      </a:r>
+                    </a:p>
+                  </a:txBody>
+                  <a:tcPr/>
+                </a:tc>
+              </a:tr>
+              <a:tr h="574765">
+                <a:tc>
+                  <a:txBody>
+                    <a:bodyPr/>
+                    <a:lstStyle/>
+                    <a:p>
+                      <a:r>
+                        <a:rPr sz="1300" b="1"/>
+                        <a:t>Comunicación</a:t>
+                      </a:r>
+                    </a:p>
+                  </a:txBody>
+                  <a:tcPr/>
+                </a:tc>
+                <a:tc>
+                  <a:txBody>
+                    <a:bodyPr/>
+                    <a:lstStyle/>
+                    <a:p>
+                      <a:r>
+                        <a:rPr sz="1300"/>
+                        <a:t>Grupo de WhatsApp saturado</a:t>
+                      </a:r>
+                    </a:p>
+                  </a:txBody>
+                  <a:tcPr/>
+                </a:tc>
+                <a:tc>
+                  <a:txBody>
+                    <a:bodyPr/>
+                    <a:lstStyle/>
+                    <a:p>
+                      <a:r>
+                        <a:rPr sz="1300"/>
+                        <a:t>Noticias y avisos segmentados: in-app, email y push</a:t>
+                      </a:r>
+                    </a:p>
+                  </a:txBody>
+                  <a:tcPr/>
+                </a:tc>
+              </a:tr>
+              <a:tr h="574770">
+                <a:tc>
+                  <a:txBody>
+                    <a:bodyPr/>
+                    <a:lstStyle/>
+                    <a:p>
+                      <a:r>
+                        <a:rPr sz="1300" b="1"/>
+                        <a:t>Decisiones</a:t>
+                      </a:r>
+                    </a:p>
+                  </a:txBody>
+                  <a:tcPr/>
+                </a:tc>
+                <a:tc>
+                  <a:txBody>
+                    <a:bodyPr/>
+                    <a:lstStyle/>
+                    <a:p>
+                      <a:r>
+                        <a:rPr sz="1300"/>
+                        <a:t>Intuición</a:t>
+                      </a:r>
+                    </a:p>
+                  </a:txBody>
+                  <a:tcPr/>
+                </a:tc>
+                <a:tc>
+                  <a:txBody>
+                    <a:bodyPr/>
+                    <a:lstStyle/>
+                    <a:p>
+                      <a:r>
+                        <a:rPr sz="1300"/>
+                        <a:t>Ocupación e ingresos registrados reales</a:t>
+                      </a:r>
+                    </a:p>
+                  </a:txBody>
+                  <a:tcPr/>
+                </a:tc>
+              </a:tr>
+            </a:tbl>
+          </a:graphicData>
+        </a:graphic>
+      </p:graphicFrame>
+      <p:sp>
+        <p:nvSpPr>
+          <p:cNvPr id="5" name="TextBox 4"/>
+          <p:cNvSpPr txBox="1"/>
+          <p:nvPr/>
+        </p:nvSpPr>
+        <p:spPr>
+          <a:xfrm>
+            <a:off x="548640" y="5897880"/>
+            <a:ext cx="8686800" cy="365760"/>
+          </a:xfrm>
+          <a:prstGeom prst="rect">
+            <a:avLst/>
+          </a:prstGeom>
+          <a:noFill/>
+        </p:spPr>
+        <p:txBody>
+          <a:bodyPr wrap="none">
+            <a:spAutoFit/>
+          </a:bodyPr>
+          <a:lstStyle/>
+          <a:p>
+            <a:r>
+              <a:rPr sz="1400" i="1"/>
+              <a:t>Sin cambiar cómo cobra el club: el pago sigue realizándose en el club.</a:t>
+            </a:r>
+          </a:p>
+        </p:txBody>
+      </p:sp>
+      <p:sp>
+        <p:nvSpPr>
+          <p:cNvPr id="6" name="TextBox 5"/>
+          <p:cNvSpPr txBox="1"/>
+          <p:nvPr/>
+        </p:nvSpPr>
+        <p:spPr>
+          <a:xfrm>
+            <a:off x="548640" y="6446520"/>
+            <a:ext cx="4572000" cy="274320"/>
+          </a:xfrm>
+          <a:prstGeom prst="rect">
+            <a:avLst/>
+          </a:prstGeom>
+          <a:noFill/>
+        </p:spPr>
+        <p:txBody>
+          <a:bodyPr wrap="none">
+            <a:spAutoFit/>
+          </a:bodyPr>
+          <a:lstStyle/>
+          <a:p>
+            <a:r>
+              <a:rPr sz="1000"/>
+              <a:t>PadelClub OS · Presentación comercial</a:t>
+            </a:r>
+          </a:p>
+        </p:txBody>
+      </p:sp>
+      <p:sp>
+        <p:nvSpPr>
+          <p:cNvPr id="7" name="page-number"/>
+          <p:cNvSpPr txBox="1"/>
+          <p:nvPr/>
+        </p:nvSpPr>
+        <p:spPr>
+          <a:xfrm>
+            <a:off x="11155680" y="6446520"/>
+            <a:ext cx="822960" cy="274320"/>
+          </a:xfrm>
+          <a:prstGeom prst="rect">
+            <a:avLst/>
+          </a:prstGeom>
+          <a:noFill/>
+        </p:spPr>
+        <p:txBody>
+          <a:bodyPr wrap="none">
+            <a:spAutoFit/>
+          </a:bodyPr>
+          <a:lstStyle/>
+          <a:p>
+            <a:r>
+              <a:rPr sz="1000"/>
+              <a:t>3 / 15</a:t>
+            </a:r>
+          </a:p>
+        </p:txBody>
+      </p:sp>
+    </p:spTree>
+  </p:cSld>
+  <p:clrMapOvr>
+    <a:masterClrMapping/>
+  </p:clrMapOvr>
 </p:sld>
 </file>
 
@@ -8230,6 +8995,10 @@
             <a:prstDash val="solid"/>
           </a:ln>
         </p:spPr>
+        <p:txBody xmlns:a="http://schemas.openxmlformats.org/drawingml/2006/main">
+          <a:bodyPr/>
+          <a:p/>
+        </p:txBody>
       </p:sp>
       <p:sp>
         <p:nvSpPr>
@@ -8276,7 +9045,7 @@
                   <a:srgbClr val="1C1A17"/>
                 </a:solidFill>
               </a:rPr>
-              <a:t>La agenda se fragmenta</a:t>
+              <a:t>La agenda vive en tres sitios</a:t>
             </a:r>
           </a:p>
         </p:txBody>
@@ -8326,7 +9095,7 @@
                   <a:srgbClr val="6E675D"/>
                 </a:solidFill>
               </a:rPr>
-              <a:t>Teléfono, WhatsApp y hojas de cálculo generan versiones distintas de la misma reserva.</a:t>
+              <a:t>Teléfono, WhatsApp y hojas de cálculo guardan versiones distintas de la misma reserva. La verdadera está en la cabeza de alguien.</a:t>
             </a:r>
           </a:p>
         </p:txBody>
@@ -8363,6 +9132,10 @@
             <a:prstDash val="solid"/>
           </a:ln>
         </p:spPr>
+        <p:txBody xmlns:a="http://schemas.openxmlformats.org/drawingml/2006/main">
+          <a:bodyPr/>
+          <a:p/>
+        </p:txBody>
       </p:sp>
       <p:sp>
         <p:nvSpPr>
@@ -8409,7 +9182,7 @@
                   <a:srgbClr val="1C1A17"/>
                 </a:solidFill>
               </a:rPr>
-              <a:t>El cobro pierde contexto</a:t>
+              <a:t>El cobro depende de la memoria</a:t>
             </a:r>
           </a:p>
         </p:txBody>
@@ -8459,7 +9232,7 @@
                   <a:srgbClr val="6E675D"/>
                 </a:solidFill>
               </a:rPr>
-              <a:t>Recepción necesita saber quién ha pagado, cuánto falta y quién registró cada cobro.</a:t>
+              <a:t>¿Quién ha pagado su parte? ¿Cuánto falta? ¿Quién lo cobró? Responder de memoria acaba costando dinero al cierre de caja.</a:t>
             </a:r>
           </a:p>
         </p:txBody>
@@ -8496,6 +9269,10 @@
             <a:prstDash val="solid"/>
           </a:ln>
         </p:spPr>
+        <p:txBody xmlns:a="http://schemas.openxmlformats.org/drawingml/2006/main">
+          <a:bodyPr/>
+          <a:p/>
+        </p:txBody>
       </p:sp>
       <p:sp>
         <p:nvSpPr>
@@ -8592,7 +9369,7 @@
                   <a:srgbClr val="6E675D"/>
                 </a:solidFill>
               </a:rPr>
-              <a:t>Socios, dirección y equipo operan con datos dispersos y decisiones difíciles de comprobar.</a:t>
+              <a:t>Cambios que no se avisan, socios que se enteran en la puerta y decisiones de negocio tomadas por intuición.</a:t>
             </a:r>
           </a:p>
         </p:txBody>
@@ -8631,6 +9408,10 @@
             <a:prstDash val="solid"/>
           </a:ln>
         </p:spPr>
+        <p:txBody xmlns:a="http://schemas.openxmlformats.org/drawingml/2006/main">
+          <a:bodyPr/>
+          <a:p/>
+        </p:txBody>
       </p:sp>
       <p:sp>
         <p:nvSpPr>
@@ -8716,6 +9497,10 @@
             <a:prstDash val="solid"/>
           </a:ln>
         </p:spPr>
+        <p:txBody xmlns:a="http://schemas.openxmlformats.org/drawingml/2006/main">
+          <a:bodyPr/>
+          <a:p/>
+        </p:txBody>
       </p:sp>
       <p:sp>
         <p:nvSpPr>
@@ -8851,6 +9636,10 @@
             <a:prstDash val="solid"/>
           </a:ln>
         </p:spPr>
+        <p:txBody xmlns:a="http://schemas.openxmlformats.org/drawingml/2006/main">
+          <a:bodyPr/>
+          <a:p/>
+        </p:txBody>
       </p:sp>
       <p:sp>
         <p:nvSpPr>
@@ -8986,6 +9775,10 @@
             <a:prstDash val="solid"/>
           </a:ln>
         </p:spPr>
+        <p:txBody xmlns:a="http://schemas.openxmlformats.org/drawingml/2006/main">
+          <a:bodyPr/>
+          <a:p/>
+        </p:txBody>
       </p:sp>
       <p:sp>
         <p:nvSpPr>
@@ -9121,6 +9914,10 @@
             <a:prstDash val="solid"/>
           </a:ln>
         </p:spPr>
+        <p:txBody xmlns:a="http://schemas.openxmlformats.org/drawingml/2006/main">
+          <a:bodyPr/>
+          <a:p/>
+        </p:txBody>
       </p:sp>
       <p:sp>
         <p:nvSpPr>
@@ -9254,6 +10051,10 @@
             <a:prstDash val="solid"/>
           </a:ln>
         </p:spPr>
+        <p:txBody xmlns:a="http://schemas.openxmlformats.org/drawingml/2006/main">
+          <a:bodyPr/>
+          <a:p/>
+        </p:txBody>
       </p:sp>
       <p:sp>
         <p:nvSpPr>
@@ -9350,7 +10151,7 @@
                   <a:srgbClr val="6E675D"/>
                 </a:solidFill>
               </a:rPr>
-              <a:t>2 / 14</a:t>
+              <a:t>2 / 15</a:t>
             </a:r>
           </a:p>
         </p:txBody>
@@ -9518,6 +10319,10 @@
             <a:prstDash val="solid"/>
           </a:ln>
         </p:spPr>
+        <p:txBody xmlns:a="http://schemas.openxmlformats.org/drawingml/2006/main">
+          <a:bodyPr/>
+          <a:p/>
+        </p:txBody>
       </p:sp>
       <p:sp>
         <p:nvSpPr>
@@ -9771,6 +10576,10 @@
             <a:prstDash val="solid"/>
           </a:ln>
         </p:spPr>
+        <p:txBody xmlns:a="http://schemas.openxmlformats.org/drawingml/2006/main">
+          <a:bodyPr/>
+          <a:p/>
+        </p:txBody>
       </p:sp>
       <p:sp>
         <p:nvSpPr>
@@ -9917,7 +10726,7 @@
                   <a:srgbClr val="6E675D"/>
                 </a:solidFill>
               </a:rPr>
-              <a:t>Reservar y cancelar</a:t>
+              <a:t>Reservar 24/7, cancelar y reagendar</a:t>
             </a:r>
           </a:p>
           <a:p xmlns:a="http://schemas.openxmlformats.org/drawingml/2006/main">
@@ -9951,6 +10760,23 @@
                   <a:srgbClr val="6E675D"/>
                 </a:solidFill>
               </a:rPr>
+              <a:t>Apuntarse a la lista de espera</a:t>
+            </a:r>
+          </a:p>
+          <a:p xmlns:a="http://schemas.openxmlformats.org/drawingml/2006/main">
+            <a:pPr algn="l">
+              <a:defRPr sz="1500" b="0">
+                <a:solidFill>
+                  <a:srgbClr val="6E675D"/>
+                </a:solidFill>
+              </a:defRPr>
+            </a:pPr>
+            <a:r>
+              <a:rPr sz="1500" b="0">
+                <a:solidFill>
+                  <a:srgbClr val="6E675D"/>
+                </a:solidFill>
+              </a:rPr>
               <a:t>Seguir competiciones y rankings</a:t>
             </a:r>
           </a:p>
@@ -9968,24 +10794,7 @@
                   <a:srgbClr val="6E675D"/>
                 </a:solidFill>
               </a:rPr>
-              <a:t>Consultar noticias y perfil</a:t>
-            </a:r>
-          </a:p>
-          <a:p xmlns:a="http://schemas.openxmlformats.org/drawingml/2006/main">
-            <a:pPr algn="l">
-              <a:defRPr sz="1500" b="0">
-                <a:solidFill>
-                  <a:srgbClr val="6E675D"/>
-                </a:solidFill>
-              </a:defRPr>
-            </a:pPr>
-            <a:r>
-              <a:rPr sz="1500" b="0">
-                <a:solidFill>
-                  <a:srgbClr val="6E675D"/>
-                </a:solidFill>
-              </a:rPr>
-              <a:t>Recibir avisos</a:t>
+              <a:t>Noticias, perfil y avisos</a:t>
             </a:r>
           </a:p>
         </p:txBody>
@@ -10072,6 +10881,10 @@
             <a:prstDash val="solid"/>
           </a:ln>
         </p:spPr>
+        <p:txBody xmlns:a="http://schemas.openxmlformats.org/drawingml/2006/main">
+          <a:bodyPr/>
+          <a:p/>
+        </p:txBody>
       </p:sp>
       <p:sp>
         <p:nvSpPr>
@@ -10168,7 +10981,7 @@
                   <a:srgbClr val="6E675D"/>
                 </a:solidFill>
               </a:rPr>
-              <a:t>3 / 14</a:t>
+              <a:t>4 / 15</a:t>
             </a:r>
           </a:p>
         </p:txBody>
@@ -10347,7 +11160,7 @@
                   <a:srgbClr val="6E675D"/>
                 </a:solidFill>
               </a:rPr>
-              <a:t>El equipo ve disponibilidad, bloqueos, partidas y estado de cobro sin reconstruir la jornada desde mensajes.</a:t>
+              <a:t>Disponibilidad, bloqueos, partidas abiertas y estado de cobro en una sola vista. Nadie vuelve a reconstruir la jornada desde mensajes.</a:t>
             </a:r>
           </a:p>
         </p:txBody>
@@ -10586,6 +11399,10 @@
             <a:prstDash val="solid"/>
           </a:ln>
         </p:spPr>
+        <p:txBody xmlns:a="http://schemas.openxmlformats.org/drawingml/2006/main">
+          <a:bodyPr/>
+          <a:p/>
+        </p:txBody>
       </p:sp>
       <p:sp>
         <p:nvSpPr>
@@ -10671,6 +11488,10 @@
             <a:prstDash val="solid"/>
           </a:ln>
         </p:spPr>
+        <p:txBody xmlns:a="http://schemas.openxmlformats.org/drawingml/2006/main">
+          <a:bodyPr/>
+          <a:p/>
+        </p:txBody>
       </p:sp>
       <p:sp>
         <p:nvSpPr>
@@ -10756,6 +11577,10 @@
             <a:prstDash val="solid"/>
           </a:ln>
         </p:spPr>
+        <p:txBody xmlns:a="http://schemas.openxmlformats.org/drawingml/2006/main">
+          <a:bodyPr/>
+          <a:p/>
+        </p:txBody>
       </p:sp>
       <p:sp>
         <p:nvSpPr>
@@ -10891,6 +11716,10 @@
             <a:prstDash val="solid"/>
           </a:ln>
         </p:spPr>
+        <p:txBody xmlns:a="http://schemas.openxmlformats.org/drawingml/2006/main">
+          <a:bodyPr/>
+          <a:p/>
+        </p:txBody>
       </p:sp>
       <p:sp>
         <p:nvSpPr>
@@ -10976,6 +11805,10 @@
             <a:prstDash val="solid"/>
           </a:ln>
         </p:spPr>
+        <p:txBody xmlns:a="http://schemas.openxmlformats.org/drawingml/2006/main">
+          <a:bodyPr/>
+          <a:p/>
+        </p:txBody>
       </p:sp>
       <p:sp>
         <p:nvSpPr>
@@ -11061,6 +11894,10 @@
             <a:prstDash val="solid"/>
           </a:ln>
         </p:spPr>
+        <p:txBody xmlns:a="http://schemas.openxmlformats.org/drawingml/2006/main">
+          <a:bodyPr/>
+          <a:p/>
+        </p:txBody>
       </p:sp>
       <p:sp>
         <p:nvSpPr>
@@ -11196,6 +12033,10 @@
             <a:prstDash val="solid"/>
           </a:ln>
         </p:spPr>
+        <p:txBody xmlns:a="http://schemas.openxmlformats.org/drawingml/2006/main">
+          <a:bodyPr/>
+          <a:p/>
+        </p:txBody>
       </p:sp>
       <p:sp>
         <p:nvSpPr>
@@ -11281,6 +12122,10 @@
             <a:prstDash val="solid"/>
           </a:ln>
         </p:spPr>
+        <p:txBody xmlns:a="http://schemas.openxmlformats.org/drawingml/2006/main">
+          <a:bodyPr/>
+          <a:p/>
+        </p:txBody>
       </p:sp>
       <p:sp>
         <p:nvSpPr>
@@ -11366,6 +12211,10 @@
             <a:prstDash val="solid"/>
           </a:ln>
         </p:spPr>
+        <p:txBody xmlns:a="http://schemas.openxmlformats.org/drawingml/2006/main">
+          <a:bodyPr/>
+          <a:p/>
+        </p:txBody>
       </p:sp>
       <p:sp>
         <p:nvSpPr>
@@ -11462,7 +12311,7 @@
                   <a:srgbClr val="0E5C3F"/>
                 </a:solidFill>
               </a:rPr>
-              <a:t>Crear, editar, cancelar, reagendar y repetir reservas desde el mismo contexto.</a:t>
+              <a:t>Crear, editar, cancelar, reagendar y repetir. Clases fijas, bloqueos y lista de espera con aviso automático al liberarse una plaza.</a:t>
             </a:r>
           </a:p>
         </p:txBody>
@@ -11499,6 +12348,10 @@
             <a:prstDash val="solid"/>
           </a:ln>
         </p:spPr>
+        <p:txBody xmlns:a="http://schemas.openxmlformats.org/drawingml/2006/main">
+          <a:bodyPr/>
+          <a:p/>
+        </p:txBody>
       </p:sp>
       <p:sp>
         <p:nvSpPr>
@@ -11595,7 +12448,7 @@
                   <a:srgbClr val="6E675D"/>
                 </a:solidFill>
               </a:rPr>
-              <a:t>4 / 14</a:t>
+              <a:t>5 / 15</a:t>
             </a:r>
           </a:p>
         </p:txBody>
@@ -11774,7 +12627,7 @@
                   <a:srgbClr val="6E675D"/>
                 </a:solidFill>
               </a:rPr>
-              <a:t>PadelClub OS registra el estado de cada jugador, el importe y la persona que cobra. El pago se realiza en el club.</a:t>
+              <a:t>Cada participante tiene su importe, su estado y la persona que registró el cobro. El pago se realiza en el club, como siempre; el control queda en el sistema.</a:t>
             </a:r>
           </a:p>
         </p:txBody>
@@ -11813,6 +12666,10 @@
             <a:prstDash val="solid"/>
           </a:ln>
         </p:spPr>
+        <p:txBody xmlns:a="http://schemas.openxmlformats.org/drawingml/2006/main">
+          <a:bodyPr/>
+          <a:p/>
+        </p:txBody>
       </p:sp>
       <p:sp>
         <p:nvSpPr>
@@ -11896,6 +12753,10 @@
             <a:prstDash val="solid"/>
           </a:ln>
         </p:spPr>
+        <p:txBody xmlns:a="http://schemas.openxmlformats.org/drawingml/2006/main">
+          <a:bodyPr/>
+          <a:p/>
+        </p:txBody>
       </p:sp>
       <p:sp>
         <p:nvSpPr>
@@ -12079,6 +12940,10 @@
             <a:prstDash val="solid"/>
           </a:ln>
         </p:spPr>
+        <p:txBody xmlns:a="http://schemas.openxmlformats.org/drawingml/2006/main">
+          <a:bodyPr/>
+          <a:p/>
+        </p:txBody>
       </p:sp>
       <p:sp>
         <p:nvSpPr>
@@ -12262,6 +13127,10 @@
             <a:prstDash val="solid"/>
           </a:ln>
         </p:spPr>
+        <p:txBody xmlns:a="http://schemas.openxmlformats.org/drawingml/2006/main">
+          <a:bodyPr/>
+          <a:p/>
+        </p:txBody>
       </p:sp>
       <p:sp>
         <p:nvSpPr>
@@ -12445,6 +13314,10 @@
             <a:prstDash val="solid"/>
           </a:ln>
         </p:spPr>
+        <p:txBody xmlns:a="http://schemas.openxmlformats.org/drawingml/2006/main">
+          <a:bodyPr/>
+          <a:p/>
+        </p:txBody>
       </p:sp>
       <p:sp>
         <p:nvSpPr>
@@ -12630,6 +13503,10 @@
             <a:prstDash val="solid"/>
           </a:ln>
         </p:spPr>
+        <p:txBody xmlns:a="http://schemas.openxmlformats.org/drawingml/2006/main">
+          <a:bodyPr/>
+          <a:p/>
+        </p:txBody>
       </p:sp>
       <p:sp>
         <p:nvSpPr>
@@ -12765,6 +13642,10 @@
             <a:prstDash val="solid"/>
           </a:ln>
         </p:spPr>
+        <p:txBody xmlns:a="http://schemas.openxmlformats.org/drawingml/2006/main">
+          <a:bodyPr/>
+          <a:p/>
+        </p:txBody>
       </p:sp>
       <p:sp>
         <p:nvSpPr>
@@ -12982,6 +13863,10 @@
             <a:prstDash val="solid"/>
           </a:ln>
         </p:spPr>
+        <p:txBody xmlns:a="http://schemas.openxmlformats.org/drawingml/2006/main">
+          <a:bodyPr/>
+          <a:p/>
+        </p:txBody>
       </p:sp>
       <p:sp>
         <p:nvSpPr>
@@ -13078,7 +13963,7 @@
                   <a:srgbClr val="6E675D"/>
                 </a:solidFill>
               </a:rPr>
-              <a:t>5 / 14</a:t>
+              <a:t>6 / 15</a:t>
             </a:r>
           </a:p>
         </p:txBody>
@@ -13257,7 +14142,7 @@
                   <a:srgbClr val="6E675D"/>
                 </a:solidFill>
               </a:rPr>
-              <a:t>El club puede importar pistas, socios y reservas desde archivos CSV compatibles con Excel en español.</a:t>
+              <a:t>Pistas con sus tarifas, socios y reservas futuras se importan desde archivos CSV compatibles con Excel en español. La vista previa valida antes de tocar nada.</a:t>
             </a:r>
           </a:p>
         </p:txBody>
@@ -13296,6 +14181,10 @@
             <a:prstDash val="solid"/>
           </a:ln>
         </p:spPr>
+        <p:txBody xmlns:a="http://schemas.openxmlformats.org/drawingml/2006/main">
+          <a:bodyPr/>
+          <a:p/>
+        </p:txBody>
       </p:sp>
       <p:sp>
         <p:nvSpPr>
@@ -13481,6 +14370,10 @@
             <a:prstDash val="solid"/>
           </a:ln>
         </p:spPr>
+        <p:txBody xmlns:a="http://schemas.openxmlformats.org/drawingml/2006/main">
+          <a:bodyPr/>
+          <a:p/>
+        </p:txBody>
       </p:sp>
       <p:sp>
         <p:nvSpPr>
@@ -13666,6 +14559,10 @@
             <a:prstDash val="solid"/>
           </a:ln>
         </p:spPr>
+        <p:txBody xmlns:a="http://schemas.openxmlformats.org/drawingml/2006/main">
+          <a:bodyPr/>
+          <a:p/>
+        </p:txBody>
       </p:sp>
       <p:sp>
         <p:nvSpPr>
@@ -13812,7 +14709,7 @@
                   <a:srgbClr val="6E675D"/>
                 </a:solidFill>
               </a:rPr>
-              <a:t>Solo entran los registros válidos y queda constancia del resultado.</a:t>
+              <a:t>Solo entran los registros válidos y queda constancia de quién importó y con qué resultado.</a:t>
             </a:r>
           </a:p>
         </p:txBody>
@@ -13899,6 +14796,10 @@
             <a:prstDash val="solid"/>
           </a:ln>
         </p:spPr>
+        <p:txBody xmlns:a="http://schemas.openxmlformats.org/drawingml/2006/main">
+          <a:bodyPr/>
+          <a:p/>
+        </p:txBody>
       </p:sp>
       <p:sp>
         <p:nvSpPr>
@@ -13995,7 +14896,7 @@
                   <a:srgbClr val="6E675D"/>
                 </a:solidFill>
               </a:rPr>
-              <a:t>6 / 14</a:t>
+              <a:t>7 / 15</a:t>
             </a:r>
           </a:p>
         </p:txBody>
@@ -14163,6 +15064,10 @@
             <a:prstDash val="solid"/>
           </a:ln>
         </p:spPr>
+        <p:txBody xmlns:a="http://schemas.openxmlformats.org/drawingml/2006/main">
+          <a:bodyPr/>
+          <a:p/>
+        </p:txBody>
       </p:sp>
       <p:sp>
         <p:nvSpPr>
@@ -14296,6 +15201,10 @@
             <a:prstDash val="solid"/>
           </a:ln>
         </p:spPr>
+        <p:txBody xmlns:a="http://schemas.openxmlformats.org/drawingml/2006/main">
+          <a:bodyPr/>
+          <a:p/>
+        </p:txBody>
       </p:sp>
       <p:sp>
         <p:nvSpPr>
@@ -14479,6 +15388,10 @@
             <a:prstDash val="solid"/>
           </a:ln>
         </p:spPr>
+        <p:txBody xmlns:a="http://schemas.openxmlformats.org/drawingml/2006/main">
+          <a:bodyPr/>
+          <a:p/>
+        </p:txBody>
       </p:sp>
       <p:sp>
         <p:nvSpPr>
@@ -14662,6 +15575,10 @@
             <a:prstDash val="solid"/>
           </a:ln>
         </p:spPr>
+        <p:txBody xmlns:a="http://schemas.openxmlformats.org/drawingml/2006/main">
+          <a:bodyPr/>
+          <a:p/>
+        </p:txBody>
       </p:sp>
       <p:sp>
         <p:nvSpPr>
@@ -14845,6 +15762,10 @@
             <a:prstDash val="solid"/>
           </a:ln>
         </p:spPr>
+        <p:txBody xmlns:a="http://schemas.openxmlformats.org/drawingml/2006/main">
+          <a:bodyPr/>
+          <a:p/>
+        </p:txBody>
       </p:sp>
       <p:sp>
         <p:nvSpPr>
@@ -14978,6 +15899,10 @@
             <a:prstDash val="solid"/>
           </a:ln>
         </p:spPr>
+        <p:txBody xmlns:a="http://schemas.openxmlformats.org/drawingml/2006/main">
+          <a:bodyPr/>
+          <a:p/>
+        </p:txBody>
       </p:sp>
       <p:sp>
         <p:nvSpPr>
@@ -15111,6 +16036,10 @@
             <a:prstDash val="solid"/>
           </a:ln>
         </p:spPr>
+        <p:txBody xmlns:a="http://schemas.openxmlformats.org/drawingml/2006/main">
+          <a:bodyPr/>
+          <a:p/>
+        </p:txBody>
       </p:sp>
       <p:sp>
         <p:nvSpPr>
@@ -15244,6 +16173,10 @@
             <a:prstDash val="solid"/>
           </a:ln>
         </p:spPr>
+        <p:txBody xmlns:a="http://schemas.openxmlformats.org/drawingml/2006/main">
+          <a:bodyPr/>
+          <a:p/>
+        </p:txBody>
       </p:sp>
       <p:sp>
         <p:nvSpPr>
@@ -15340,7 +16273,7 @@
                   <a:srgbClr val="6E675D"/>
                 </a:solidFill>
               </a:rPr>
-              <a:t>7 / 14</a:t>
+              <a:t>8 / 15</a:t>
             </a:r>
           </a:p>
         </p:txBody>
@@ -15519,7 +16452,7 @@
                   <a:srgbClr val="6E675D"/>
                 </a:solidFill>
               </a:rPr>
-              <a:t>El club publica noticias y prepara comunicaciones para audiencias concretas desde una única herramienta.</a:t>
+              <a:t>Noticias para lo estable, comunicaciones segmentadas para lo puntual. El aviso correcto, a la audiencia correcta, una sola vez.</a:t>
             </a:r>
           </a:p>
         </p:txBody>
@@ -15558,6 +16491,10 @@
             <a:prstDash val="solid"/>
           </a:ln>
         </p:spPr>
+        <p:txBody xmlns:a="http://schemas.openxmlformats.org/drawingml/2006/main">
+          <a:bodyPr/>
+          <a:p/>
+        </p:txBody>
       </p:sp>
       <p:sp>
         <p:nvSpPr>
@@ -15591,6 +16528,10 @@
             <a:prstDash val="solid"/>
           </a:ln>
         </p:spPr>
+        <p:txBody xmlns:a="http://schemas.openxmlformats.org/drawingml/2006/main">
+          <a:bodyPr/>
+          <a:p/>
+        </p:txBody>
       </p:sp>
       <p:sp>
         <p:nvSpPr>
@@ -15726,6 +16667,10 @@
             <a:prstDash val="solid"/>
           </a:ln>
         </p:spPr>
+        <p:txBody xmlns:a="http://schemas.openxmlformats.org/drawingml/2006/main">
+          <a:bodyPr/>
+          <a:p/>
+        </p:txBody>
       </p:sp>
       <p:sp>
         <p:nvSpPr>
@@ -15759,6 +16704,10 @@
             <a:prstDash val="solid"/>
           </a:ln>
         </p:spPr>
+        <p:txBody xmlns:a="http://schemas.openxmlformats.org/drawingml/2006/main">
+          <a:bodyPr/>
+          <a:p/>
+        </p:txBody>
       </p:sp>
       <p:sp>
         <p:nvSpPr>
@@ -15894,6 +16843,10 @@
             <a:prstDash val="solid"/>
           </a:ln>
         </p:spPr>
+        <p:txBody xmlns:a="http://schemas.openxmlformats.org/drawingml/2006/main">
+          <a:bodyPr/>
+          <a:p/>
+        </p:txBody>
       </p:sp>
       <p:sp>
         <p:nvSpPr>
@@ -15927,6 +16880,10 @@
             <a:prstDash val="solid"/>
           </a:ln>
         </p:spPr>
+        <p:txBody xmlns:a="http://schemas.openxmlformats.org/drawingml/2006/main">
+          <a:bodyPr/>
+          <a:p/>
+        </p:txBody>
       </p:sp>
       <p:sp>
         <p:nvSpPr>
@@ -16062,6 +17019,10 @@
             <a:prstDash val="solid"/>
           </a:ln>
         </p:spPr>
+        <p:txBody xmlns:a="http://schemas.openxmlformats.org/drawingml/2006/main">
+          <a:bodyPr/>
+          <a:p/>
+        </p:txBody>
       </p:sp>
       <p:sp>
         <p:nvSpPr>
@@ -16347,6 +17308,10 @@
             <a:prstDash val="solid"/>
           </a:ln>
         </p:spPr>
+        <p:txBody xmlns:a="http://schemas.openxmlformats.org/drawingml/2006/main">
+          <a:bodyPr/>
+          <a:p/>
+        </p:txBody>
       </p:sp>
       <p:sp>
         <p:nvSpPr>
@@ -16430,6 +17395,10 @@
             <a:prstDash val="solid"/>
           </a:ln>
         </p:spPr>
+        <p:txBody xmlns:a="http://schemas.openxmlformats.org/drawingml/2006/main">
+          <a:bodyPr/>
+          <a:p/>
+        </p:txBody>
       </p:sp>
       <p:sp>
         <p:nvSpPr>
@@ -16526,7 +17495,7 @@
                   <a:srgbClr val="6E675D"/>
                 </a:solidFill>
               </a:rPr>
-              <a:t>8 / 14</a:t>
+              <a:t>9 / 15</a:t>
             </a:r>
           </a:p>
         </p:txBody>
@@ -16744,6 +17713,10 @@
             <a:prstDash val="solid"/>
           </a:ln>
         </p:spPr>
+        <p:txBody xmlns:a="http://schemas.openxmlformats.org/drawingml/2006/main">
+          <a:bodyPr/>
+          <a:p/>
+        </p:txBody>
       </p:sp>
       <p:sp>
         <p:nvSpPr>
@@ -16879,6 +17852,10 @@
             <a:prstDash val="solid"/>
           </a:ln>
         </p:spPr>
+        <p:txBody xmlns:a="http://schemas.openxmlformats.org/drawingml/2006/main">
+          <a:bodyPr/>
+          <a:p/>
+        </p:txBody>
       </p:sp>
       <p:sp>
         <p:nvSpPr>
@@ -17014,6 +17991,10 @@
             <a:prstDash val="solid"/>
           </a:ln>
         </p:spPr>
+        <p:txBody xmlns:a="http://schemas.openxmlformats.org/drawingml/2006/main">
+          <a:bodyPr/>
+          <a:p/>
+        </p:txBody>
       </p:sp>
       <p:sp>
         <p:nvSpPr>
@@ -17197,6 +18178,10 @@
             <a:prstDash val="solid"/>
           </a:ln>
         </p:spPr>
+        <p:txBody xmlns:a="http://schemas.openxmlformats.org/drawingml/2006/main">
+          <a:bodyPr/>
+          <a:p/>
+        </p:txBody>
       </p:sp>
       <p:sp>
         <p:nvSpPr>
@@ -17293,7 +18278,7 @@
                   <a:srgbClr val="A39C8E"/>
                 </a:solidFill>
               </a:rPr>
-              <a:t>9 / 14</a:t>
+              <a:t>10 / 15</a:t>
             </a:r>
           </a:p>
         </p:txBody>

</xml_diff>